<commit_message>
feat: update project documentation with GitHub repository link and website link
</commit_message>
<xml_diff>
--- a/ZeroWaste_Hackathon.pptx
+++ b/ZeroWaste_Hackathon.pptx
@@ -6694,8 +6694,9 @@
                 <a:latin typeface="Calibri" pitchFamily="34" charset="0"/>
                 <a:ea typeface="Calibri" pitchFamily="34" charset="-122"/>
                 <a:cs typeface="Calibri" pitchFamily="34" charset="-120"/>
-              </a:rPr>
-              <a:t>Full source • MIT License • TypeScript</a:t>
+                <a:hlinkClick r:id="rId4"/>
+              </a:rPr>
+              <a:t>https://github.com/addy9691/zerowaste.git</a:t>
             </a:r>
             <a:endParaRPr lang="en-US" sz="900" dirty="0"/>
           </a:p>
@@ -6710,7 +6711,7 @@
           <p:nvPr/>
         </p:nvPicPr>
         <p:blipFill>
-          <a:blip r:embed="rId4"/>
+          <a:blip r:embed="rId5"/>
           <a:stretch>
             <a:fillRect/>
           </a:stretch>
@@ -6749,6 +6750,19 @@
             <a:pPr marL="0" indent="0">
               <a:buNone/>
             </a:pPr>
+            <a:endParaRPr lang="en-US" sz="1100" b="1" dirty="0">
+              <a:solidFill>
+                <a:srgbClr val="FFFFFF"/>
+              </a:solidFill>
+              <a:latin typeface="Calibri" pitchFamily="34" charset="0"/>
+              <a:ea typeface="Calibri" pitchFamily="34" charset="-122"/>
+              <a:cs typeface="Calibri" pitchFamily="34" charset="-120"/>
+            </a:endParaRPr>
+          </a:p>
+          <a:p>
+            <a:pPr marL="0" indent="0">
+              <a:buNone/>
+            </a:pPr>
             <a:r>
               <a:rPr lang="en-US" sz="1100" b="1" dirty="0">
                 <a:solidFill>
@@ -6760,6 +6774,11 @@
               </a:rPr>
               <a:t>Live MVP Prototype</a:t>
             </a:r>
+          </a:p>
+          <a:p>
+            <a:pPr marL="0" indent="0">
+              <a:buNone/>
+            </a:pPr>
             <a:endParaRPr lang="en-US" sz="1100" dirty="0"/>
           </a:p>
         </p:txBody>
@@ -6784,6 +6803,31 @@
         <p:txBody>
           <a:bodyPr wrap="square" lIns="0" tIns="0" rIns="0" bIns="0" rtlCol="0" anchor="ctr"/>
           <a:lstStyle/>
+          <a:p>
+            <a:pPr marL="0" indent="0">
+              <a:buNone/>
+            </a:pPr>
+            <a:r>
+              <a:rPr lang="en-US" sz="900" dirty="0">
+                <a:solidFill>
+                  <a:srgbClr val="718096"/>
+                </a:solidFill>
+                <a:latin typeface="Calibri" pitchFamily="34" charset="0"/>
+                <a:ea typeface="Calibri" pitchFamily="34" charset="-122"/>
+                <a:cs typeface="Calibri" pitchFamily="34" charset="-120"/>
+                <a:hlinkClick r:id="rId6"/>
+              </a:rPr>
+              <a:t>WEBSITE LINK</a:t>
+            </a:r>
+            <a:endParaRPr lang="en-US" sz="900" dirty="0">
+              <a:solidFill>
+                <a:srgbClr val="718096"/>
+              </a:solidFill>
+              <a:latin typeface="Calibri" pitchFamily="34" charset="0"/>
+              <a:ea typeface="Calibri" pitchFamily="34" charset="-122"/>
+              <a:cs typeface="Calibri" pitchFamily="34" charset="-120"/>
+            </a:endParaRPr>
+          </a:p>
           <a:p>
             <a:pPr marL="0" indent="0">
               <a:buNone/>

</xml_diff>